<commit_message>
Fill both columns on every page, add a transposed trace table
- draw_case: place the auxiliary tables with a small two-column flow
  (height first via sd.panel_height, skip what does not fit) so the
  example pages no longer leave a half-empty column; the causal/overview
  pages gained the panels they were missing
- axis page rebuilt: order grid, per-core assignment grid, and a third
  panel showing how one dS column becomes one dK/dV row (the reason for
  column-private), plus the task-id expansion table
- sd.trace_table: rows = cores, columns = rounds, cell = the column that
  core holds that round - the transposed view of the task matrix
- seeten_draw: panel/block_grid cells accept "\n"; sd.panel_height helper;
  _text_extents now anchors wrapped text by its wrapped line count
- color-sets: new `plain` preset (no semantics to encode)
- docs: skill rule + two recipes (auxiliary tables, two-column filling)
</commit_message>
<xml_diff>
--- a/examples/demo.pptx
+++ b/examples/demo.pptx
@@ -6398,7 +6398,7 @@
           <p:nvPr/>
         </p:nvGraphicFramePr>
         <p:xfrm>
-          <a:off x="5120640" y="8147304"/>
+          <a:off x="5120640" y="8220456"/>
           <a:ext cx="7315200" cy="1207008"/>
         </p:xfrm>
         <a:graphic>
@@ -6777,7 +6777,7 @@
           <a:noFill/>
         </p:spPr>
         <p:txBody>
-          <a:bodyPr wrap="none" anchor="ctr" lIns="0" rIns="0" tIns="0" bIns="0">
+          <a:bodyPr wrap="square" anchor="ctr" lIns="0" rIns="0" tIns="0" bIns="0">
             <a:spAutoFit/>
           </a:bodyPr>
           <a:lstStyle/>
@@ -8622,7 +8622,7 @@
           <p:nvPr/>
         </p:nvGraphicFramePr>
         <p:xfrm>
-          <a:off x="667512" y="7173468"/>
+          <a:off x="667512" y="7246620"/>
           <a:ext cx="4251960" cy="2011680"/>
         </p:xfrm>
         <a:graphic>
@@ -9210,7 +9210,7 @@
           <a:noFill/>
         </p:spPr>
         <p:txBody>
-          <a:bodyPr wrap="none" anchor="ctr" lIns="0" rIns="0" tIns="0" bIns="0">
+          <a:bodyPr wrap="square" anchor="ctr" lIns="0" rIns="0" tIns="0" bIns="0">
             <a:spAutoFit/>
           </a:bodyPr>
           <a:lstStyle/>
@@ -10362,7 +10362,7 @@
         </p:nvSpPr>
         <p:spPr>
           <a:xfrm>
-            <a:off x="10277855" y="2560320"/>
+            <a:off x="10277855" y="2505456"/>
             <a:ext cx="2926080" cy="274320"/>
           </a:xfrm>
           <a:prstGeom prst="rect">
@@ -10399,8 +10399,8 @@
         </p:nvCxnSpPr>
         <p:spPr>
           <a:xfrm>
-            <a:off x="10332719" y="2852928"/>
-            <a:ext cx="0" cy="73152"/>
+            <a:off x="10332719" y="2825496"/>
+            <a:ext cx="0" cy="100584"/>
           </a:xfrm>
           <a:prstGeom prst="line">
             <a:avLst/>

</xml_diff>